<commit_message>
Charts, left and right side content on a slide, English template
</commit_message>
<xml_diff>
--- a/MFUA-Template.pptx
+++ b/MFUA-Template.pptx
@@ -211,7 +211,7 @@
           <a:p>
             <a:fld id="{957754D8-7103-4E45-B3A2-3FAA684C25FB}" type="datetimeFigureOut">
               <a:rPr lang="ru-RU" smtClean="0"/>
-              <a:t>19.09.2026</a:t>
+              <a:t>29.10.2026</a:t>
             </a:fld>
             <a:endParaRPr lang="ru-RU"/>
           </a:p>
@@ -657,7 +657,7 @@
           <a:p>
             <a:fld id="{7918BB92-FF5D-420D-B990-B9BFEFF71E1B}" type="datetime1">
               <a:rPr lang="ru-RU" smtClean="0"/>
-              <a:t>19.09.2026</a:t>
+              <a:t>29.10.2026</a:t>
             </a:fld>
             <a:endParaRPr lang="ru-RU"/>
           </a:p>
@@ -826,7 +826,7 @@
           <a:p>
             <a:fld id="{E835D151-3A55-4F29-9977-376FABA37879}" type="datetime1">
               <a:rPr lang="ru-RU" smtClean="0"/>
-              <a:t>19.09.2026</a:t>
+              <a:t>29.10.2026</a:t>
             </a:fld>
             <a:endParaRPr lang="ru-RU"/>
           </a:p>
@@ -1005,7 +1005,7 @@
           <a:p>
             <a:fld id="{3955BE08-E8EB-43A5-80C1-28B3D5E9D029}" type="datetime1">
               <a:rPr lang="ru-RU" smtClean="0"/>
-              <a:t>19.09.2026</a:t>
+              <a:t>29.10.2026</a:t>
             </a:fld>
             <a:endParaRPr lang="ru-RU"/>
           </a:p>
@@ -1139,6 +1139,8 @@
               </a:defRPr>
             </a:lvl1pPr>
             <a:lvl2pPr>
+              <a:buFont typeface="Arial" panose="020B0604020202020204" pitchFamily="34" charset="0"/>
+              <a:buChar char="•"/>
               <a:defRPr>
                 <a:latin typeface="Times New Roman" panose="02020603050405020304" pitchFamily="18" charset="0"/>
                 <a:cs typeface="Times New Roman" panose="02020603050405020304" pitchFamily="18" charset="0"/>
@@ -1217,7 +1219,7 @@
           <a:p>
             <a:fld id="{FF1EAE16-5351-4286-8ED5-9258824D3730}" type="datetime1">
               <a:rPr lang="ru-RU" smtClean="0"/>
-              <a:t>19.09.2026</a:t>
+              <a:t>29.10.2026</a:t>
             </a:fld>
             <a:endParaRPr lang="ru-RU"/>
           </a:p>
@@ -1468,7 +1470,7 @@
           <a:p>
             <a:fld id="{70264D9E-1F07-4E03-8550-AEBE7BDCA6AD}" type="datetime1">
               <a:rPr lang="ru-RU" smtClean="0"/>
-              <a:t>19.09.2026</a:t>
+              <a:t>29.10.2026</a:t>
             </a:fld>
             <a:endParaRPr lang="ru-RU"/>
           </a:p>
@@ -1754,7 +1756,7 @@
           <a:p>
             <a:fld id="{40A3A8AB-E6E4-4214-BE2D-A949F92A3075}" type="datetime1">
               <a:rPr lang="ru-RU" smtClean="0"/>
-              <a:t>19.09.2026</a:t>
+              <a:t>29.10.2026</a:t>
             </a:fld>
             <a:endParaRPr lang="ru-RU"/>
           </a:p>
@@ -2174,7 +2176,7 @@
           <a:p>
             <a:fld id="{0BDA358B-D8E4-4F66-9258-7EDF101A1B19}" type="datetime1">
               <a:rPr lang="ru-RU" smtClean="0"/>
-              <a:t>19.09.2026</a:t>
+              <a:t>29.10.2026</a:t>
             </a:fld>
             <a:endParaRPr lang="ru-RU"/>
           </a:p>
@@ -2292,7 +2294,7 @@
           <a:p>
             <a:fld id="{E80EA859-60CB-4B14-95B8-0D262D9FD385}" type="datetime1">
               <a:rPr lang="ru-RU" smtClean="0"/>
-              <a:t>19.09.2026</a:t>
+              <a:t>29.10.2026</a:t>
             </a:fld>
             <a:endParaRPr lang="ru-RU"/>
           </a:p>
@@ -2388,7 +2390,7 @@
           <a:p>
             <a:fld id="{0A94720C-71C1-4E72-B8F3-ADB3CE2DAB6A}" type="datetime1">
               <a:rPr lang="ru-RU" smtClean="0"/>
-              <a:t>19.09.2026</a:t>
+              <a:t>29.10.2026</a:t>
             </a:fld>
             <a:endParaRPr lang="ru-RU"/>
           </a:p>
@@ -2664,7 +2666,7 @@
           <a:p>
             <a:fld id="{D95FB63C-4DE1-4851-AFAB-2A0A73BBE76D}" type="datetime1">
               <a:rPr lang="ru-RU" smtClean="0"/>
-              <a:t>19.09.2026</a:t>
+              <a:t>29.10.2026</a:t>
             </a:fld>
             <a:endParaRPr lang="ru-RU"/>
           </a:p>
@@ -2920,7 +2922,7 @@
           <a:p>
             <a:fld id="{E0DA7845-D8BA-4A80-8965-C90368CF863A}" type="datetime1">
               <a:rPr lang="ru-RU" smtClean="0"/>
-              <a:t>19.09.2026</a:t>
+              <a:t>29.10.2026</a:t>
             </a:fld>
             <a:endParaRPr lang="ru-RU"/>
           </a:p>
@@ -3141,7 +3143,7 @@
           <a:p>
             <a:fld id="{A01763D2-20A2-4DD5-B0E0-5C8BF9814CEB}" type="datetime1">
               <a:rPr lang="ru-RU" smtClean="0"/>
-              <a:t>19.09.2026</a:t>
+              <a:t>29.10.2026</a:t>
             </a:fld>
             <a:endParaRPr lang="ru-RU"/>
           </a:p>

</xml_diff>